<commit_message>
prepare repository for public release
- add MIT LICENSE
- polish README for public consumption
- add CLIL and presentation knowledge modules
- add assistant skills (.agents/skills)
- add workshops/package.json for slide generation
- harden .gitignore
- restructure knowledge base (remove unused domain folders)
</commit_message>
<xml_diff>
--- a/workshops/session1-ai-introduction.pptx
+++ b/workshops/session1-ai-introduction.pptx
@@ -512,7 +512,9 @@
           <a:p>
             <a:r>
               <a:rPr lang="en-US" dirty="0"/>
-              <a:t/>
+              <a:t>خوش‌آمدگویی و معرفی کارگاه.
+مثال کارشده: سارا هر روز ۳۰ دقیقه ایمیل‌ها را می‌خواند و خلاصه می‌کند. یک روز یک ربات این کار را در ۲ دقیقه انجام داد. سارا نگران شد: یعنی من بی‌کار شدم؟ نه! حالا ۲۸ دقیقه بیشتر برای فکرکردن دارد.
+هدف: نه جایگزینی انسان، بلکه آزادکردن زمان انسان.</a:t>
             </a:r>
             <a:endParaRPr lang="en-US" dirty="0"/>
           </a:p>
@@ -600,7 +602,8 @@
           <a:p>
             <a:r>
               <a:rPr lang="en-US" dirty="0"/>
-              <a:t/>
+              <a:t>این جدول را سریع مرور کنید. نیازی به حفظ‌کردن تاریخ‌ها نیست؛ هدف نشان‌دادن روند تحول است.
+نکته: هر نسل از نسل قبل بهتر شده، ولی هنوز کامل نیست.</a:t>
             </a:r>
             <a:endParaRPr lang="en-US" dirty="0"/>
           </a:p>
@@ -688,7 +691,9 @@
           <a:p>
             <a:r>
               <a:rPr lang="en-US" dirty="0"/>
-              <a:t/>
+              <a:t>مثال کارشده: سؤال بسته‌شونده.
+از شرکت‌کنندگان بپرسید: «اگر یک دستیار هوشمند داشتید که فقط یکی از سه رکن (دانش، مهارت، ابزار) را داشت، کدام را انتخاب می‌کردید و چرا؟»
+این سؤال باعث می‌شود هر سه رکن در ذهنشان تثبیت شود.</a:t>
             </a:r>
             <a:endParaRPr lang="en-US" dirty="0"/>
           </a:p>
@@ -776,7 +781,7 @@
           <a:p>
             <a:r>
               <a:rPr lang="en-US" dirty="0"/>
-              <a:t/>
+              <a:t>خلاصهٔ مسیر جلسه. اشاره کنید که امروز فقط مفاهیم پایه را می‌بینیم و در جلسات بعد عمیق‌تر می‌شویم.</a:t>
             </a:r>
             <a:endParaRPr lang="en-US" dirty="0"/>
           </a:p>
@@ -864,7 +869,7 @@
           <a:p>
             <a:r>
               <a:rPr lang="en-US" dirty="0"/>
-              <a:t/>
+              <a:t>این اهداف را سریع مرور کنید. نیازی به توضیح نیست؛ فقط بگویید «در پایان کارگاه می‌توانید...». هدف ایجاد انگیزه و نقشهٔ ذهنی است.</a:t>
             </a:r>
             <a:endParaRPr lang="en-US" dirty="0"/>
           </a:p>
@@ -952,7 +957,13 @@
           <a:p>
             <a:r>
               <a:rPr lang="en-US" dirty="0"/>
-              <a:t/>
+              <a:t>مثال کارشده: آزمایش سریع.
+از ChatGPT بخواهید «ایمیل‌های امروزم را بخوان و خلاصه کن.» — نمی‌تواند.
+چرا؟ سه رکن ندارد:
+• دانش ندارد: نمی‌داند ایمیل‌های شما کجاست
+• مهارت ندارد: نمی‌داند خلاصه را کجا بفرستد
+• ابزار ندارد: نمی‌تواند به ایمیل‌های شما دسترسی پیدا کند
+سپس بپرسید: «اگر هر سه رکن فراهم شود، چه اتفاقی می‌افتد؟» — بله، دستیار هوشمند!</a:t>
             </a:r>
             <a:endParaRPr lang="en-US" dirty="0"/>
           </a:p>
@@ -1040,7 +1051,12 @@
           <a:p>
             <a:r>
               <a:rPr lang="en-US" dirty="0"/>
-              <a:t/>
+              <a:t>مثال کارشده: صبح کاری با دستیار هوشمند.
+ساعت ۸ صبح، دستیار هوشمند شما:
+• ایمیل‌های دیشب را خوانده (ابزار)
+• دو طرح جدید را با اهداف سازمان تطبیق داده (دانش)
+• چون مهلت ثبت‌نام فردا تمام می‌شود، هشدار داده (مهارت)
+از شرکت‌کنندگان بپرسید: «کدام بخش این صبح را یک جست‌وجوی ساده می‌توانست انجام دهد؟» — پاسخ: هیچ‌کدام؛ چون هر سه رکن با هم کار می‌کنند.</a:t>
             </a:r>
             <a:endParaRPr lang="en-US" dirty="0"/>
           </a:p>
@@ -1128,7 +1144,9 @@
           <a:p>
             <a:r>
               <a:rPr lang="en-US" dirty="0"/>
-              <a:t/>
+              <a:t>مثال کارشده: تصور کنید.
+مدیر طرح‌ها: «تصور کنید صبح بیدار شدید و گوشی‌تان یک خلاصهٔ ۵ خطی از ۲۰ طرح دیشب دارد.»
+دانشجوی پژوهشگر: «تصور کنید از مدل بپرسید: مقالات اخیر دربارهٔ X چه می‌گویند؟ و ۳ مقالهٔ کلیدی با خلاصه بگیرید.»</a:t>
             </a:r>
             <a:endParaRPr lang="en-US" dirty="0"/>
           </a:p>
@@ -1216,7 +1234,9 @@
           <a:p>
             <a:r>
               <a:rPr lang="en-US" dirty="0"/>
-              <a:t/>
+              <a:t>مثال کارشده: تصور کنید.
+برنامه‌نویس: «تصور کنید کدتان را به مدل بدهید و بگویید: این باگ کجاست؟ و فوراً جواب بگیرید.»
+دستیار قضایی: «تصور کنید مدل هر صبح به شما بگوید: امروز ۳ مهلت مهم دارید!»</a:t>
             </a:r>
             <a:endParaRPr lang="en-US" dirty="0"/>
           </a:p>
@@ -1304,7 +1324,10 @@
           <a:p>
             <a:r>
               <a:rPr lang="en-US" dirty="0"/>
-              <a:t/>
+              <a:t>مثال کارشده: مقایسهٔ سیستم ساده و هوش مصنوعی.
+سیستم ساده: ماشین حساب — ۲+۲=۴ (قانون ثابت، انسان نوشته)
+هوش مصنوعی: مدلی که عکس سگ و گربه را تشخیص می‌دهد (الگو یاد گرفته، خودش از داده)
+نکته: هوش مصنوعی یعنی ماشین بتواند یاد بگیرد، نه فقط قانون را اجرا کند.</a:t>
             </a:r>
             <a:endParaRPr lang="en-US" dirty="0"/>
           </a:p>
@@ -1392,7 +1415,11 @@
           <a:p>
             <a:r>
               <a:rPr lang="en-US" dirty="0"/>
-              <a:t/>
+              <a:t>مثال کارشده: تشخیص چهره در عکس.
+• AI (هوش مصنوعی): هر سیستمی که بتواند چهره تشخیص دهد
+• ML (یادگیری ماشین): سیستمی که از هزاران عکس یاد گرفته
+• DL (یادگیری عمیق): سیستمی با شبکه‌های عصبی عمیق
+به‌زبان ساده: DL ⊂ ML ⊂ AI — مثل عروسک‌های توی هم.</a:t>
             </a:r>
             <a:endParaRPr lang="en-US" dirty="0"/>
           </a:p>
@@ -3095,7 +3122,7 @@
       </p:graphicFrame>
       <p:sp>
         <p:nvSpPr>
-          <p:cNvPr id="5" name="Text 2"/>
+          <p:cNvPr id="6" name="Text 2"/>
           <p:cNvSpPr/>
           <p:nvPr/>
         </p:nvSpPr>
@@ -3134,7 +3161,7 @@
       </p:sp>
       <p:sp>
         <p:nvSpPr>
-          <p:cNvPr id="6" name="Text 3"/>
+          <p:cNvPr id="7" name="Text 3"/>
           <p:cNvSpPr/>
           <p:nvPr/>
         </p:nvSpPr>
@@ -3373,7 +3400,7 @@
       </p:sp>
       <p:sp>
         <p:nvSpPr>
-          <p:cNvPr id="5" name="Text 3"/>
+          <p:cNvPr id="6" name="Text 3"/>
           <p:cNvSpPr/>
           <p:nvPr/>
         </p:nvSpPr>
@@ -3412,7 +3439,7 @@
       </p:sp>
       <p:sp>
         <p:nvSpPr>
-          <p:cNvPr id="6" name="Text 4"/>
+          <p:cNvPr id="7" name="Text 4"/>
           <p:cNvSpPr/>
           <p:nvPr/>
         </p:nvSpPr>
@@ -3672,7 +3699,7 @@
       </p:sp>
       <p:sp>
         <p:nvSpPr>
-          <p:cNvPr id="5" name="Text 3"/>
+          <p:cNvPr id="6" name="Text 3"/>
           <p:cNvSpPr/>
           <p:nvPr/>
         </p:nvSpPr>
@@ -3711,7 +3738,7 @@
       </p:sp>
       <p:sp>
         <p:nvSpPr>
-          <p:cNvPr id="6" name="Text 4"/>
+          <p:cNvPr id="7" name="Text 4"/>
           <p:cNvSpPr/>
           <p:nvPr/>
         </p:nvSpPr>
@@ -4098,7 +4125,7 @@
       </p:sp>
       <p:sp>
         <p:nvSpPr>
-          <p:cNvPr id="7" name="Text 5"/>
+          <p:cNvPr id="8" name="Text 5"/>
           <p:cNvSpPr/>
           <p:nvPr/>
         </p:nvSpPr>
@@ -4137,7 +4164,7 @@
       </p:sp>
       <p:sp>
         <p:nvSpPr>
-          <p:cNvPr id="8" name="Text 6"/>
+          <p:cNvPr id="9" name="Text 6"/>
           <p:cNvSpPr/>
           <p:nvPr/>
         </p:nvSpPr>
@@ -4376,7 +4403,7 @@
       </p:sp>
       <p:sp>
         <p:nvSpPr>
-          <p:cNvPr id="5" name="Text 3"/>
+          <p:cNvPr id="6" name="Text 3"/>
           <p:cNvSpPr/>
           <p:nvPr/>
         </p:nvSpPr>
@@ -4415,7 +4442,7 @@
       </p:sp>
       <p:sp>
         <p:nvSpPr>
-          <p:cNvPr id="6" name="Text 4"/>
+          <p:cNvPr id="7" name="Text 4"/>
           <p:cNvSpPr/>
           <p:nvPr/>
         </p:nvSpPr>
@@ -5007,7 +5034,7 @@
       </p:sp>
       <p:sp>
         <p:nvSpPr>
-          <p:cNvPr id="18" name="Text 16"/>
+          <p:cNvPr id="19" name="Text 16"/>
           <p:cNvSpPr/>
           <p:nvPr/>
         </p:nvSpPr>
@@ -5046,7 +5073,7 @@
       </p:sp>
       <p:sp>
         <p:nvSpPr>
-          <p:cNvPr id="19" name="Text 17"/>
+          <p:cNvPr id="20" name="Text 17"/>
           <p:cNvSpPr/>
           <p:nvPr/>
         </p:nvSpPr>
@@ -5591,7 +5618,7 @@
       </p:sp>
       <p:sp>
         <p:nvSpPr>
-          <p:cNvPr id="13" name="Text 11"/>
+          <p:cNvPr id="14" name="Text 11"/>
           <p:cNvSpPr/>
           <p:nvPr/>
         </p:nvSpPr>
@@ -5630,7 +5657,7 @@
       </p:sp>
       <p:sp>
         <p:nvSpPr>
-          <p:cNvPr id="14" name="Text 12"/>
+          <p:cNvPr id="15" name="Text 12"/>
           <p:cNvSpPr/>
           <p:nvPr/>
         </p:nvSpPr>
@@ -6136,7 +6163,7 @@
       </p:sp>
       <p:sp>
         <p:nvSpPr>
-          <p:cNvPr id="12" name="Text 10"/>
+          <p:cNvPr id="13" name="Text 10"/>
           <p:cNvSpPr/>
           <p:nvPr/>
         </p:nvSpPr>
@@ -6175,7 +6202,7 @@
       </p:sp>
       <p:sp>
         <p:nvSpPr>
-          <p:cNvPr id="13" name="Text 11"/>
+          <p:cNvPr id="14" name="Text 11"/>
           <p:cNvSpPr/>
           <p:nvPr/>
         </p:nvSpPr>
@@ -6393,7 +6420,7 @@
       </p:sp>
       <p:sp>
         <p:nvSpPr>
-          <p:cNvPr id="5" name="Text 3"/>
+          <p:cNvPr id="6" name="Text 3"/>
           <p:cNvSpPr/>
           <p:nvPr/>
         </p:nvSpPr>
@@ -6432,7 +6459,7 @@
       </p:sp>
       <p:sp>
         <p:nvSpPr>
-          <p:cNvPr id="6" name="Text 4"/>
+          <p:cNvPr id="7" name="Text 4"/>
           <p:cNvSpPr/>
           <p:nvPr/>
         </p:nvSpPr>
@@ -6896,7 +6923,7 @@
       </p:sp>
       <p:sp>
         <p:nvSpPr>
-          <p:cNvPr id="14" name="Text 12"/>
+          <p:cNvPr id="15" name="Text 12"/>
           <p:cNvSpPr/>
           <p:nvPr/>
         </p:nvSpPr>
@@ -6935,7 +6962,7 @@
       </p:sp>
       <p:sp>
         <p:nvSpPr>
-          <p:cNvPr id="15" name="Text 13"/>
+          <p:cNvPr id="16" name="Text 13"/>
           <p:cNvSpPr/>
           <p:nvPr/>
         </p:nvSpPr>

</xml_diff>